<commit_message>
docs(sih-deck): embed God's Eye 3D C2 screenshot and MapLibre stack in Slide 3
</commit_message>
<xml_diff>
--- a/docs/sih/SIH2026_IDEA_Presentation_SIH26083_Official.pptx
+++ b/docs/sih/SIH2026_IDEA_Presentation_SIH26083_Official.pptx
@@ -4792,7 +4792,7 @@
               </a:defRPr>
             </a:pPr>
             <a:r>
-              <a:t>• 4. Automated Action: </a:t>
+              <a:t>• 4. God's Eye C2 &amp; Action: </a:t>
             </a:r>
             <a:r>
               <a:rPr b="0">
@@ -4800,14 +4800,14 @@
                   <a:srgbClr val="1E293B"/>
                 </a:solidFill>
               </a:rPr>
-              <a:t>Interactive Leaflet GIS map, 25 REST APIs, NDMA playbooks, hospital cooling beds, NIOSH labor halts.</a:t>
+              <a:t>Tactical 3D Command View (MapLibre), 25 REST APIs, NDMA playbooks, hospital cooling beds, NIOSH labor halts.</a:t>
             </a:r>
           </a:p>
         </p:txBody>
       </p:sp>
       <p:pic>
         <p:nvPicPr>
-          <p:cNvPr id="7" name="Picture 6" descr="slide3_gis_curves.png"/>
+          <p:cNvPr id="7" name="Picture 6" descr="gods-eye-c2.png"/>
           <p:cNvPicPr>
             <a:picLocks noChangeAspect="1"/>
           </p:cNvPicPr>
@@ -4939,7 +4939,7 @@
               </a:defRPr>
             </a:pPr>
             <a:r>
-              <a:t>❖  Web GIS &amp; Visualization: </a:t>
+              <a:t>❖  Web GIS &amp; Tactical 3D C2: </a:t>
             </a:r>
             <a:r>
               <a:rPr b="0">
@@ -4947,7 +4947,7 @@
                   <a:srgbClr val="1E293B"/>
                 </a:solidFill>
               </a:rPr>
-              <a:t>Leaflet.js (Choropleth GIS), Chart.js (5-Day Trend Curves), HTML5/CSS3 Responsive UI</a:t>
+              <a:t>MapLibre GL JS (God's Eye 3D C2 War Room), Leaflet.js (2D Choropleth), Chart.js (5-Day Trend Curves)</a:t>
             </a:r>
           </a:p>
           <a:p>

</xml_diff>

<commit_message>
docs(sih-deck): adapt exact reference winning architecture layout for Slide 3 (Technical Approach)
</commit_message>
<xml_diff>
--- a/docs/sih/SIH2026_IDEA_Presentation_SIH26083_Official.pptx
+++ b/docs/sih/SIH2026_IDEA_Presentation_SIH26083_Official.pptx
@@ -4659,26 +4659,50 @@
           </a:p>
         </p:txBody>
       </p:sp>
-      <p:sp>
-        <p:nvSpPr>
-          <p:cNvPr id="6" name="Rounded Rectangle 5"/>
+      <p:pic>
+        <p:nvPicPr>
+          <p:cNvPr id="6" name="Picture 5" descr="slide3_technical_approach_reference.png"/>
+          <p:cNvPicPr>
+            <a:picLocks noChangeAspect="1"/>
+          </p:cNvPicPr>
+          <p:nvPr/>
+        </p:nvPicPr>
+        <p:blipFill>
+          <a:blip r:embed="rId3"/>
+          <a:stretch>
+            <a:fillRect/>
+          </a:stretch>
+        </p:blipFill>
+        <p:spPr>
+          <a:xfrm>
+            <a:off x="731520" y="1234440"/>
+            <a:ext cx="10728655" cy="3291840"/>
+          </a:xfrm>
+          <a:prstGeom prst="rect">
+            <a:avLst/>
+          </a:prstGeom>
+        </p:spPr>
+      </p:pic>
+      <p:sp>
+        <p:nvSpPr>
+          <p:cNvPr id="7" name="Rounded Rectangle 6"/>
           <p:cNvSpPr/>
           <p:nvPr/>
         </p:nvSpPr>
         <p:spPr>
           <a:xfrm>
-            <a:off x="731520" y="1280160"/>
-            <a:ext cx="5120640" cy="3200400"/>
+            <a:off x="731520" y="4663440"/>
+            <a:ext cx="10728655" cy="1645920"/>
           </a:xfrm>
           <a:prstGeom prst="roundRect">
             <a:avLst/>
           </a:prstGeom>
           <a:solidFill>
-            <a:srgbClr val="FFFFFF"/>
+            <a:srgbClr val="F8FAFC"/>
           </a:solidFill>
-          <a:ln w="19050">
+          <a:ln w="15240">
             <a:solidFill>
-              <a:srgbClr val="0284C7"/>
+              <a:srgbClr val="CBD5E1"/>
             </a:solidFill>
           </a:ln>
         </p:spPr>
@@ -4697,33 +4721,33 @@
           </a:fontRef>
         </p:style>
         <p:txBody>
-          <a:bodyPr rtlCol="0" anchor="ctr" wrap="square" lIns="0" tIns="0" rIns="0" bIns="0"/>
+          <a:bodyPr rtlCol="0" anchor="ctr" wrap="square"/>
           <a:lstStyle/>
           <a:p>
             <a:pPr algn="ctr">
-              <a:defRPr sz="1000" b="1">
+              <a:defRPr sz="1050" b="1">
                 <a:solidFill>
                   <a:srgbClr val="1D4E89"/>
                 </a:solidFill>
               </a:defRPr>
             </a:pPr>
             <a:r>
-              <a:t>4-STAGE COMPUTATIONAL PIPELINE</a:t>
+              <a:t>• Technologies to be used (Programming Languages, Frameworks, GIS &amp; Deployment Platforms):</a:t>
             </a:r>
           </a:p>
           <a:p>
             <a:pPr>
               <a:spcBef>
-                <a:spcPts val="300"/>
+                <a:spcPts val="200"/>
               </a:spcBef>
-              <a:defRPr sz="850" b="1">
+              <a:defRPr sz="900" b="1">
                 <a:solidFill>
                   <a:srgbClr val="1D4E89"/>
                 </a:solidFill>
               </a:defRPr>
             </a:pPr>
             <a:r>
-              <a:t>• 1. Ingestion: </a:t>
+              <a:t>❖  Programming Languages &amp; Web: </a:t>
             </a:r>
             <a:r>
               <a:rPr b="0">
@@ -4731,22 +4755,22 @@
                   <a:srgbClr val="1E293B"/>
                 </a:solidFill>
               </a:rPr>
-              <a:t>Open-Meteo 0.1° NWP 5-day hourly weather + NASA POWER 40-yr baseline + Census 2011 PCA demographics.</a:t>
+              <a:t>Python 3.11, JavaScript (ES6+), HTML5, Tailwind CSS, AsyncIO (FastAPI 25 REST Endpoints)</a:t>
             </a:r>
           </a:p>
           <a:p>
             <a:pPr>
               <a:spcBef>
-                <a:spcPts val="300"/>
+                <a:spcPts val="200"/>
               </a:spcBef>
-              <a:defRPr sz="850" b="1">
+              <a:defRPr sz="900" b="1">
                 <a:solidFill>
                   <a:srgbClr val="1D4E89"/>
                 </a:solidFill>
               </a:defRPr>
             </a:pPr>
             <a:r>
-              <a:t>• 2. Thermal Engine: </a:t>
+              <a:t>❖  AI / ML &amp; Biometeorology Frameworks: </a:t>
             </a:r>
             <a:r>
               <a:rPr b="0">
@@ -4754,22 +4778,22 @@
                   <a:srgbClr val="1E293B"/>
                 </a:solidFill>
               </a:rPr>
-              <a:t>UTCI 6th-order polynomial (Fiala) + ISO 7243 WBGT psychrometrics + Multi-day persistence penalty (Dmult).</a:t>
+              <a:t>NumPy, Pandas, GeoPandas, Shapely, Scipy, Fiala 187-Node UTCI Polynomial, ISO 7243 WBGT</a:t>
             </a:r>
           </a:p>
           <a:p>
             <a:pPr>
               <a:spcBef>
-                <a:spcPts val="300"/>
+                <a:spcPts val="200"/>
               </a:spcBef>
-              <a:defRPr sz="850" b="1">
+              <a:defRPr sz="900" b="1">
                 <a:solidFill>
                   <a:srgbClr val="1D4E89"/>
                 </a:solidFill>
               </a:defRPr>
             </a:pPr>
             <a:r>
-              <a:t>• 3. AI &amp; HVI Synthesis: </a:t>
+              <a:t>❖  Cloud, GIS &amp; Deployment Platforms: </a:t>
             </a:r>
             <a:r>
               <a:rPr b="0">
@@ -4777,79 +4801,30 @@
                   <a:srgbClr val="1E293B"/>
                 </a:solidFill>
               </a:rPr>
-              <a:t>PCA Demographic Vulnerability Index (slums, elderly, gig labor, canopy deficit) → 0–100 Heat-Health Score.</a:t>
-            </a:r>
-          </a:p>
-          <a:p>
-            <a:pPr>
-              <a:spcBef>
-                <a:spcPts val="300"/>
-              </a:spcBef>
-              <a:defRPr sz="850" b="1">
-                <a:solidFill>
-                  <a:srgbClr val="1D4E89"/>
-                </a:solidFill>
-              </a:defRPr>
-            </a:pPr>
-            <a:r>
-              <a:t>• 4. God's Eye C2 &amp; Action: </a:t>
-            </a:r>
-            <a:r>
-              <a:rPr b="0">
-                <a:solidFill>
-                  <a:srgbClr val="1E293B"/>
-                </a:solidFill>
-              </a:rPr>
-              <a:t>Tactical 3D Command View (MapLibre), 25 REST APIs, NDMA playbooks, hospital cooling beds, NIOSH labor halts.</a:t>
-            </a:r>
-          </a:p>
-        </p:txBody>
-      </p:sp>
-      <p:pic>
-        <p:nvPicPr>
-          <p:cNvPr id="7" name="Picture 6" descr="gods-eye-c2.png"/>
-          <p:cNvPicPr>
-            <a:picLocks noChangeAspect="1"/>
-          </p:cNvPicPr>
+              <a:t>Docker, Docker Compose, Linux VPS (Oracle Cloud), Nginx (SSL/TLS), GitHub CI/CD, MapLibre GL, Leaflet</a:t>
+            </a:r>
+          </a:p>
+        </p:txBody>
+      </p:sp>
+      <p:sp>
+        <p:nvSpPr>
+          <p:cNvPr id="8" name="Rectangle 7"/>
+          <p:cNvSpPr/>
           <p:nvPr/>
-        </p:nvPicPr>
-        <p:blipFill>
-          <a:blip r:embed="rId3"/>
-          <a:stretch>
-            <a:fillRect/>
-          </a:stretch>
-        </p:blipFill>
-        <p:spPr>
-          <a:xfrm>
-            <a:off x="6035040" y="1280160"/>
-            <a:ext cx="5425135" cy="3200400"/>
+        </p:nvSpPr>
+        <p:spPr>
+          <a:xfrm>
+            <a:off x="0" y="6446520"/>
+            <a:ext cx="12191695" cy="411480"/>
           </a:xfrm>
           <a:prstGeom prst="rect">
             <a:avLst/>
           </a:prstGeom>
-        </p:spPr>
-      </p:pic>
-      <p:sp>
-        <p:nvSpPr>
-          <p:cNvPr id="8" name="Rounded Rectangle 7"/>
-          <p:cNvSpPr/>
-          <p:nvPr/>
-        </p:nvSpPr>
-        <p:spPr>
-          <a:xfrm>
-            <a:off x="731520" y="4617720"/>
-            <a:ext cx="10728655" cy="1691640"/>
-          </a:xfrm>
-          <a:prstGeom prst="roundRect">
-            <a:avLst/>
-          </a:prstGeom>
           <a:solidFill>
-            <a:srgbClr val="F8FAFC"/>
+            <a:srgbClr val="0073C6"/>
           </a:solidFill>
-          <a:ln w="15240">
-            <a:solidFill>
-              <a:srgbClr val="CBD5E1"/>
-            </a:solidFill>
+          <a:ln>
+            <a:noFill/>
           </a:ln>
         </p:spPr>
         <p:style>
@@ -4867,150 +4842,6 @@
           </a:fontRef>
         </p:style>
         <p:txBody>
-          <a:bodyPr rtlCol="0" anchor="ctr" wrap="square"/>
-          <a:lstStyle/>
-          <a:p>
-            <a:pPr algn="ctr">
-              <a:defRPr sz="1050" b="1">
-                <a:solidFill>
-                  <a:srgbClr val="1D4E89"/>
-                </a:solidFill>
-              </a:defRPr>
-            </a:pPr>
-            <a:r>
-              <a:t>• Technologies to be used (Programming Languages, Frameworks, GIS &amp; Deployment):</a:t>
-            </a:r>
-          </a:p>
-          <a:p>
-            <a:pPr>
-              <a:spcBef>
-                <a:spcPts val="200"/>
-              </a:spcBef>
-              <a:defRPr sz="900" b="1">
-                <a:solidFill>
-                  <a:srgbClr val="1D4E89"/>
-                </a:solidFill>
-              </a:defRPr>
-            </a:pPr>
-            <a:r>
-              <a:t>❖  Backend &amp; REST APIs: </a:t>
-            </a:r>
-            <a:r>
-              <a:rPr b="0">
-                <a:solidFill>
-                  <a:srgbClr val="1E293B"/>
-                </a:solidFill>
-              </a:rPr>
-              <a:t>Python 3.11, FastAPI, Pydantic v2, Uvicorn, AsyncIO (25 REST production endpoints)</a:t>
-            </a:r>
-          </a:p>
-          <a:p>
-            <a:pPr>
-              <a:spcBef>
-                <a:spcPts val="200"/>
-              </a:spcBef>
-              <a:defRPr sz="900" b="1">
-                <a:solidFill>
-                  <a:srgbClr val="1D4E89"/>
-                </a:solidFill>
-              </a:defRPr>
-            </a:pPr>
-            <a:r>
-              <a:t>❖  Biometeorology &amp; GIS Engine: </a:t>
-            </a:r>
-            <a:r>
-              <a:rPr b="0">
-                <a:solidFill>
-                  <a:srgbClr val="1E293B"/>
-                </a:solidFill>
-              </a:rPr>
-              <a:t>NumPy, Pandas, GeoPandas, Shapely, Scipy (UTCI 6th-order polynomial &amp; ISO 7243 psychrometrics)</a:t>
-            </a:r>
-          </a:p>
-          <a:p>
-            <a:pPr>
-              <a:spcBef>
-                <a:spcPts val="200"/>
-              </a:spcBef>
-              <a:defRPr sz="900" b="1">
-                <a:solidFill>
-                  <a:srgbClr val="1D4E89"/>
-                </a:solidFill>
-              </a:defRPr>
-            </a:pPr>
-            <a:r>
-              <a:t>❖  Web GIS &amp; Tactical 3D C2: </a:t>
-            </a:r>
-            <a:r>
-              <a:rPr b="0">
-                <a:solidFill>
-                  <a:srgbClr val="1E293B"/>
-                </a:solidFill>
-              </a:rPr>
-              <a:t>MapLibre GL JS (God's Eye 3D C2 War Room), Leaflet.js (2D Choropleth), Chart.js (5-Day Trend Curves)</a:t>
-            </a:r>
-          </a:p>
-          <a:p>
-            <a:pPr>
-              <a:spcBef>
-                <a:spcPts val="200"/>
-              </a:spcBef>
-              <a:defRPr sz="900" b="1">
-                <a:solidFill>
-                  <a:srgbClr val="1D4E89"/>
-                </a:solidFill>
-              </a:defRPr>
-            </a:pPr>
-            <a:r>
-              <a:t>❖  Data Ingestion &amp; Deployment: </a:t>
-            </a:r>
-            <a:r>
-              <a:rPr b="0">
-                <a:solidFill>
-                  <a:srgbClr val="1E293B"/>
-                </a:solidFill>
-              </a:rPr>
-              <a:t>Open-Meteo NWP, NASA POWER MERRA-2, Census India PCA, Docker, Linux VPS (Oracle Linux)</a:t>
-            </a:r>
-          </a:p>
-        </p:txBody>
-      </p:sp>
-      <p:sp>
-        <p:nvSpPr>
-          <p:cNvPr id="9" name="Rectangle 8"/>
-          <p:cNvSpPr/>
-          <p:nvPr/>
-        </p:nvSpPr>
-        <p:spPr>
-          <a:xfrm>
-            <a:off x="0" y="6446520"/>
-            <a:ext cx="12191695" cy="411480"/>
-          </a:xfrm>
-          <a:prstGeom prst="rect">
-            <a:avLst/>
-          </a:prstGeom>
-          <a:solidFill>
-            <a:srgbClr val="0073C6"/>
-          </a:solidFill>
-          <a:ln>
-            <a:noFill/>
-          </a:ln>
-        </p:spPr>
-        <p:style>
-          <a:lnRef idx="1">
-            <a:schemeClr val="accent1"/>
-          </a:lnRef>
-          <a:fillRef idx="3">
-            <a:schemeClr val="accent1"/>
-          </a:fillRef>
-          <a:effectRef idx="2">
-            <a:schemeClr val="accent1"/>
-          </a:effectRef>
-          <a:fontRef idx="minor">
-            <a:schemeClr val="lt1"/>
-          </a:fontRef>
-        </p:style>
-        <p:txBody>
           <a:bodyPr rtlCol="0" anchor="ctr"/>
           <a:lstStyle/>
           <a:p>
@@ -5020,7 +4851,7 @@
       </p:sp>
       <p:sp>
         <p:nvSpPr>
-          <p:cNvPr id="10" name="TextBox 9"/>
+          <p:cNvPr id="9" name="TextBox 8"/>
           <p:cNvSpPr txBox="1"/>
           <p:nvPr/>
         </p:nvSpPr>
@@ -5056,7 +4887,7 @@
       </p:sp>
       <p:sp>
         <p:nvSpPr>
-          <p:cNvPr id="11" name="TextBox 10"/>
+          <p:cNvPr id="10" name="TextBox 9"/>
           <p:cNvSpPr txBox="1"/>
           <p:nvPr/>
         </p:nvSpPr>

</xml_diff>